<commit_message>
chore: update and restore image assets
</commit_message>
<xml_diff>
--- a/docs/.offline/social-banner.pptx
+++ b/docs/.offline/social-banner.pptx
@@ -299,7 +299,7 @@
           <a:p>
             <a:fld id="{28E28D72-4025-431C-8D57-0B5AB3027359}" type="datetimeFigureOut">
               <a:rPr lang="en-US" smtClean="0"/>
-              <a:t>4/7/2024</a:t>
+              <a:t>6/22/2026</a:t>
             </a:fld>
             <a:endParaRPr lang="en-US"/>
           </a:p>
@@ -464,7 +464,7 @@
           <a:p>
             <a:fld id="{93BE4712-1341-4BAD-BD21-6ECE0BEF80F7}" type="datetimeFigureOut">
               <a:rPr lang="en-US" smtClean="0"/>
-              <a:t>4/7/2024</a:t>
+              <a:t>6/22/2026</a:t>
             </a:fld>
             <a:endParaRPr lang="en-US" dirty="0"/>
           </a:p>
@@ -3806,10 +3806,10 @@
       </p:grpSpPr>
       <p:pic>
         <p:nvPicPr>
-          <p:cNvPr id="12" name="Graphic 11">
+          <p:cNvPr id="3" name="Graphic 2">
             <a:extLst>
               <a:ext uri="{FF2B5EF4-FFF2-40B4-BE49-F238E27FC236}">
-                <a16:creationId xmlns:a16="http://schemas.microsoft.com/office/drawing/2014/main" id="{F4A5326F-F71E-2681-A6BF-455604F584A0}"/>
+                <a16:creationId xmlns:a16="http://schemas.microsoft.com/office/drawing/2014/main" id="{A74CCD26-939C-D5DB-C0C3-5161650F6D54}"/>
               </a:ext>
             </a:extLst>
           </p:cNvPr>
@@ -3821,9 +3821,6 @@
         <p:blipFill>
           <a:blip r:embed="rId2">
             <a:extLst>
-              <a:ext uri="{28A0092B-C50C-407E-A947-70E740481C1C}">
-                <a14:useLocalDpi xmlns:a14="http://schemas.microsoft.com/office/drawing/2010/main" val="0"/>
-              </a:ext>
               <a:ext uri="{96DAC541-7B7A-43D3-8B79-37D633B846F1}">
                 <asvg:svgBlip xmlns:asvg="http://schemas.microsoft.com/office/drawing/2016/SVG/main" r:embed="rId3"/>
               </a:ext>
@@ -5373,9 +5370,12 @@
 </file>
 
 <file path=customXml/item1.xml><?xml version="1.0" encoding="utf-8"?>
-<p:properties xmlns:p="http://schemas.microsoft.com/office/2006/metadata/properties" xmlns:xsi="http://www.w3.org/2001/XMLSchema-instance" xmlns:pc="http://schemas.microsoft.com/office/infopath/2007/PartnerControls">
-  <documentManagement/>
-</p:properties>
+<?mso-contentType ?>
+<FormTemplates xmlns="http://schemas.microsoft.com/sharepoint/v3/contenttype/forms">
+  <Display>DocumentLibraryForm</Display>
+  <Edit>DocumentLibraryForm</Edit>
+  <New>DocumentLibraryForm</New>
+</FormTemplates>
 </file>
 
 <file path=customXml/item2.xml><?xml version="1.0" encoding="utf-8"?>
@@ -5602,27 +5602,15 @@
 </file>
 
 <file path=customXml/item3.xml><?xml version="1.0" encoding="utf-8"?>
-<?mso-contentType ?>
-<FormTemplates xmlns="http://schemas.microsoft.com/sharepoint/v3/contenttype/forms">
-  <Display>DocumentLibraryForm</Display>
-  <Edit>DocumentLibraryForm</Edit>
-  <New>DocumentLibraryForm</New>
-</FormTemplates>
+<p:properties xmlns:p="http://schemas.microsoft.com/office/2006/metadata/properties" xmlns:xsi="http://www.w3.org/2001/XMLSchema-instance" xmlns:pc="http://schemas.microsoft.com/office/infopath/2007/PartnerControls">
+  <documentManagement/>
+</p:properties>
 </file>
 
 <file path=customXml/itemProps1.xml><?xml version="1.0" encoding="utf-8"?>
-<ds:datastoreItem xmlns:ds="http://schemas.openxmlformats.org/officeDocument/2006/customXml" ds:itemID="{014BA3A2-63E0-4B7F-B3DE-3A95B2486FE0}">
+<ds:datastoreItem xmlns:ds="http://schemas.openxmlformats.org/officeDocument/2006/customXml" ds:itemID="{E6410E9E-9826-4829-BED7-2515B80346D8}">
   <ds:schemaRefs>
-    <ds:schemaRef ds:uri="http://purl.org/dc/elements/1.1/"/>
-    <ds:schemaRef ds:uri="http://schemas.microsoft.com/office/2006/metadata/properties"/>
-    <ds:schemaRef ds:uri="http://schemas.openxmlformats.org/package/2006/metadata/core-properties"/>
-    <ds:schemaRef ds:uri="http://purl.org/dc/terms/"/>
-    <ds:schemaRef ds:uri="http://schemas.microsoft.com/office/infopath/2007/PartnerControls"/>
-    <ds:schemaRef ds:uri="http://schemas.microsoft.com/office/2006/documentManagement/types"/>
-    <ds:schemaRef ds:uri="a65e1435-cce4-4b60-b931-95dd04145ae4"/>
-    <ds:schemaRef ds:uri="62bc8c9b-251f-48fe-a6ec-75d721adcbf9"/>
-    <ds:schemaRef ds:uri="http://www.w3.org/XML/1998/namespace"/>
-    <ds:schemaRef ds:uri="http://purl.org/dc/dcmitype/"/>
+    <ds:schemaRef ds:uri="http://schemas.microsoft.com/sharepoint/v3/contenttype/forms"/>
   </ds:schemaRefs>
 </ds:datastoreItem>
 </file>
@@ -5647,9 +5635,18 @@
 </file>
 
 <file path=customXml/itemProps3.xml><?xml version="1.0" encoding="utf-8"?>
-<ds:datastoreItem xmlns:ds="http://schemas.openxmlformats.org/officeDocument/2006/customXml" ds:itemID="{E6410E9E-9826-4829-BED7-2515B80346D8}">
+<ds:datastoreItem xmlns:ds="http://schemas.openxmlformats.org/officeDocument/2006/customXml" ds:itemID="{014BA3A2-63E0-4B7F-B3DE-3A95B2486FE0}">
   <ds:schemaRefs>
-    <ds:schemaRef ds:uri="http://schemas.microsoft.com/sharepoint/v3/contenttype/forms"/>
+    <ds:schemaRef ds:uri="http://purl.org/dc/elements/1.1/"/>
+    <ds:schemaRef ds:uri="http://schemas.microsoft.com/office/2006/metadata/properties"/>
+    <ds:schemaRef ds:uri="http://schemas.openxmlformats.org/package/2006/metadata/core-properties"/>
+    <ds:schemaRef ds:uri="http://purl.org/dc/terms/"/>
+    <ds:schemaRef ds:uri="http://schemas.microsoft.com/office/infopath/2007/PartnerControls"/>
+    <ds:schemaRef ds:uri="http://schemas.microsoft.com/office/2006/documentManagement/types"/>
+    <ds:schemaRef ds:uri="a65e1435-cce4-4b60-b931-95dd04145ae4"/>
+    <ds:schemaRef ds:uri="62bc8c9b-251f-48fe-a6ec-75d721adcbf9"/>
+    <ds:schemaRef ds:uri="http://www.w3.org/XML/1998/namespace"/>
+    <ds:schemaRef ds:uri="http://purl.org/dc/dcmitype/"/>
   </ds:schemaRefs>
 </ds:datastoreItem>
 </file>
</xml_diff>

<commit_message>
chore: Update Repo URLs and pkg deploy (#2118)
</commit_message>
<xml_diff>
--- a/docs/.offline/social-banner.pptx
+++ b/docs/.offline/social-banner.pptx
@@ -299,7 +299,7 @@
           <a:p>
             <a:fld id="{28E28D72-4025-431C-8D57-0B5AB3027359}" type="datetimeFigureOut">
               <a:rPr lang="en-US" smtClean="0"/>
-              <a:t>4/7/2024</a:t>
+              <a:t>6/22/2026</a:t>
             </a:fld>
             <a:endParaRPr lang="en-US"/>
           </a:p>
@@ -464,7 +464,7 @@
           <a:p>
             <a:fld id="{93BE4712-1341-4BAD-BD21-6ECE0BEF80F7}" type="datetimeFigureOut">
               <a:rPr lang="en-US" smtClean="0"/>
-              <a:t>4/7/2024</a:t>
+              <a:t>6/22/2026</a:t>
             </a:fld>
             <a:endParaRPr lang="en-US" dirty="0"/>
           </a:p>
@@ -3806,10 +3806,10 @@
       </p:grpSpPr>
       <p:pic>
         <p:nvPicPr>
-          <p:cNvPr id="12" name="Graphic 11">
+          <p:cNvPr id="3" name="Graphic 2">
             <a:extLst>
               <a:ext uri="{FF2B5EF4-FFF2-40B4-BE49-F238E27FC236}">
-                <a16:creationId xmlns:a16="http://schemas.microsoft.com/office/drawing/2014/main" id="{F4A5326F-F71E-2681-A6BF-455604F584A0}"/>
+                <a16:creationId xmlns:a16="http://schemas.microsoft.com/office/drawing/2014/main" id="{A74CCD26-939C-D5DB-C0C3-5161650F6D54}"/>
               </a:ext>
             </a:extLst>
           </p:cNvPr>
@@ -3821,9 +3821,6 @@
         <p:blipFill>
           <a:blip r:embed="rId2">
             <a:extLst>
-              <a:ext uri="{28A0092B-C50C-407E-A947-70E740481C1C}">
-                <a14:useLocalDpi xmlns:a14="http://schemas.microsoft.com/office/drawing/2010/main" val="0"/>
-              </a:ext>
               <a:ext uri="{96DAC541-7B7A-43D3-8B79-37D633B846F1}">
                 <asvg:svgBlip xmlns:asvg="http://schemas.microsoft.com/office/drawing/2016/SVG/main" r:embed="rId3"/>
               </a:ext>
@@ -5373,9 +5370,12 @@
 </file>
 
 <file path=customXml/item1.xml><?xml version="1.0" encoding="utf-8"?>
-<p:properties xmlns:p="http://schemas.microsoft.com/office/2006/metadata/properties" xmlns:xsi="http://www.w3.org/2001/XMLSchema-instance" xmlns:pc="http://schemas.microsoft.com/office/infopath/2007/PartnerControls">
-  <documentManagement/>
-</p:properties>
+<?mso-contentType ?>
+<FormTemplates xmlns="http://schemas.microsoft.com/sharepoint/v3/contenttype/forms">
+  <Display>DocumentLibraryForm</Display>
+  <Edit>DocumentLibraryForm</Edit>
+  <New>DocumentLibraryForm</New>
+</FormTemplates>
 </file>
 
 <file path=customXml/item2.xml><?xml version="1.0" encoding="utf-8"?>
@@ -5602,27 +5602,15 @@
 </file>
 
 <file path=customXml/item3.xml><?xml version="1.0" encoding="utf-8"?>
-<?mso-contentType ?>
-<FormTemplates xmlns="http://schemas.microsoft.com/sharepoint/v3/contenttype/forms">
-  <Display>DocumentLibraryForm</Display>
-  <Edit>DocumentLibraryForm</Edit>
-  <New>DocumentLibraryForm</New>
-</FormTemplates>
+<p:properties xmlns:p="http://schemas.microsoft.com/office/2006/metadata/properties" xmlns:xsi="http://www.w3.org/2001/XMLSchema-instance" xmlns:pc="http://schemas.microsoft.com/office/infopath/2007/PartnerControls">
+  <documentManagement/>
+</p:properties>
 </file>
 
 <file path=customXml/itemProps1.xml><?xml version="1.0" encoding="utf-8"?>
-<ds:datastoreItem xmlns:ds="http://schemas.openxmlformats.org/officeDocument/2006/customXml" ds:itemID="{014BA3A2-63E0-4B7F-B3DE-3A95B2486FE0}">
+<ds:datastoreItem xmlns:ds="http://schemas.openxmlformats.org/officeDocument/2006/customXml" ds:itemID="{E6410E9E-9826-4829-BED7-2515B80346D8}">
   <ds:schemaRefs>
-    <ds:schemaRef ds:uri="http://purl.org/dc/elements/1.1/"/>
-    <ds:schemaRef ds:uri="http://schemas.microsoft.com/office/2006/metadata/properties"/>
-    <ds:schemaRef ds:uri="http://schemas.openxmlformats.org/package/2006/metadata/core-properties"/>
-    <ds:schemaRef ds:uri="http://purl.org/dc/terms/"/>
-    <ds:schemaRef ds:uri="http://schemas.microsoft.com/office/infopath/2007/PartnerControls"/>
-    <ds:schemaRef ds:uri="http://schemas.microsoft.com/office/2006/documentManagement/types"/>
-    <ds:schemaRef ds:uri="a65e1435-cce4-4b60-b931-95dd04145ae4"/>
-    <ds:schemaRef ds:uri="62bc8c9b-251f-48fe-a6ec-75d721adcbf9"/>
-    <ds:schemaRef ds:uri="http://www.w3.org/XML/1998/namespace"/>
-    <ds:schemaRef ds:uri="http://purl.org/dc/dcmitype/"/>
+    <ds:schemaRef ds:uri="http://schemas.microsoft.com/sharepoint/v3/contenttype/forms"/>
   </ds:schemaRefs>
 </ds:datastoreItem>
 </file>
@@ -5647,9 +5635,18 @@
 </file>
 
 <file path=customXml/itemProps3.xml><?xml version="1.0" encoding="utf-8"?>
-<ds:datastoreItem xmlns:ds="http://schemas.openxmlformats.org/officeDocument/2006/customXml" ds:itemID="{E6410E9E-9826-4829-BED7-2515B80346D8}">
+<ds:datastoreItem xmlns:ds="http://schemas.openxmlformats.org/officeDocument/2006/customXml" ds:itemID="{014BA3A2-63E0-4B7F-B3DE-3A95B2486FE0}">
   <ds:schemaRefs>
-    <ds:schemaRef ds:uri="http://schemas.microsoft.com/sharepoint/v3/contenttype/forms"/>
+    <ds:schemaRef ds:uri="http://purl.org/dc/elements/1.1/"/>
+    <ds:schemaRef ds:uri="http://schemas.microsoft.com/office/2006/metadata/properties"/>
+    <ds:schemaRef ds:uri="http://schemas.openxmlformats.org/package/2006/metadata/core-properties"/>
+    <ds:schemaRef ds:uri="http://purl.org/dc/terms/"/>
+    <ds:schemaRef ds:uri="http://schemas.microsoft.com/office/infopath/2007/PartnerControls"/>
+    <ds:schemaRef ds:uri="http://schemas.microsoft.com/office/2006/documentManagement/types"/>
+    <ds:schemaRef ds:uri="a65e1435-cce4-4b60-b931-95dd04145ae4"/>
+    <ds:schemaRef ds:uri="62bc8c9b-251f-48fe-a6ec-75d721adcbf9"/>
+    <ds:schemaRef ds:uri="http://www.w3.org/XML/1998/namespace"/>
+    <ds:schemaRef ds:uri="http://purl.org/dc/dcmitype/"/>
   </ds:schemaRefs>
 </ds:datastoreItem>
 </file>
</xml_diff>